<commit_message>
Integrar API pública, dispersión/correlación, regresión con R² y actualizar documentación
</commit_message>
<xml_diff>
--- a/informe/DEFENSA_SAFEANALYTICS_EC.pptx
+++ b/informe/DEFENSA_SAFEANALYTICS_EC.pptx
@@ -2764,6 +2764,10 @@
             <a:prstDash val="solid"/>
           </a:ln>
         </p:spPr>
+        <p:txBody>
+          <a:bodyPr/>
+          <a:p/>
+        </p:txBody>
       </p:sp>
       <p:sp>
         <p:nvSpPr>
@@ -2899,6 +2903,10 @@
             <a:prstDash val="solid"/>
           </a:ln>
         </p:spPr>
+        <p:txBody>
+          <a:bodyPr/>
+          <a:p/>
+        </p:txBody>
       </p:sp>
       <p:sp>
         <p:nvSpPr>
@@ -3034,6 +3042,10 @@
             <a:prstDash val="solid"/>
           </a:ln>
         </p:spPr>
+        <p:txBody>
+          <a:bodyPr/>
+          <a:p/>
+        </p:txBody>
       </p:sp>
       <p:sp>
         <p:nvSpPr>
@@ -3169,6 +3181,10 @@
             <a:prstDash val="solid"/>
           </a:ln>
         </p:spPr>
+        <p:txBody>
+          <a:bodyPr/>
+          <a:p/>
+        </p:txBody>
       </p:sp>
       <p:sp>
         <p:nvSpPr>
@@ -3365,7 +3381,7 @@
                   <a:srgbClr val="17202A"/>
                 </a:solidFill>
               </a:rPr>
-              <a:t>• Dashboard Streamlit y Power BI para monitoreo ejecutivo.</a:t>
+              <a:t>• Fuentes: Excel oficial del MDI + API pública (Banco Mundial) para la tasa por 100.000 hab.</a:t>
             </a:r>
           </a:p>
         </p:txBody>
@@ -3642,6 +3658,10 @@
             <a:prstDash val="solid"/>
           </a:ln>
         </p:spPr>
+        <p:txBody>
+          <a:bodyPr/>
+          <a:p/>
+        </p:txBody>
       </p:sp>
       <p:sp>
         <p:nvSpPr>
@@ -3688,7 +3708,7 @@
                   <a:srgbClr val="12355B"/>
                 </a:solidFill>
               </a:rPr>
-              <a:t>Fuente real</a:t>
+              <a:t>Fuentes de datos</a:t>
             </a:r>
           </a:p>
         </p:txBody>
@@ -3738,24 +3758,7 @@
                   <a:srgbClr val="17202A"/>
                 </a:solidFill>
               </a:rPr>
-              <a:t>Excel MDI</a:t>
-            </a:r>
-          </a:p>
-          <a:p>
-            <a:pPr>
-              <a:defRPr sz="1575" b="0">
-                <a:solidFill>
-                  <a:srgbClr val="17202A"/>
-                </a:solidFill>
-              </a:defRPr>
-            </a:pPr>
-            <a:r>
-              <a:rPr sz="1575" b="0">
-                <a:solidFill>
-                  <a:srgbClr val="17202A"/>
-                </a:solidFill>
-              </a:rPr>
-              <a:t>enero-mayo 2026</a:t>
+              <a:t>Excel MDI + API Banco Mundial</a:t>
             </a:r>
           </a:p>
         </p:txBody>
@@ -4637,6 +4640,10 @@
             <a:prstDash val="solid"/>
           </a:ln>
         </p:spPr>
+        <p:txBody>
+          <a:bodyPr/>
+          <a:p/>
+        </p:txBody>
       </p:sp>
       <p:sp>
         <p:nvSpPr>
@@ -4733,7 +4740,7 @@
                   <a:srgbClr val="17202A"/>
                 </a:solidFill>
               </a:rPr>
-              <a:t>• Guayas concentra el mayor volumen de casos.</a:t>
+              <a:t>• Guayas: 1.521 casos; CV provincial de 218% (extrema).</a:t>
             </a:r>
           </a:p>
         </p:txBody>
@@ -4783,7 +4790,7 @@
                   <a:srgbClr val="17202A"/>
                 </a:solidFill>
               </a:rPr>
-              <a:t>• Guayaquil lidera el ranking cantonal.</a:t>
+              <a:t>• Guayaquil lidera el ranking cantonal con 944 casos.</a:t>
             </a:r>
           </a:p>
         </p:txBody>
@@ -4833,7 +4840,7 @@
                   <a:srgbClr val="17202A"/>
                 </a:solidFill>
               </a:rPr>
-              <a:t>• La priorización no debe confundirse con causalidad.</a:t>
+              <a:t>• Volumen y cantones correlacionan r=0,91; no es causalidad.</a:t>
             </a:r>
           </a:p>
         </p:txBody>
@@ -5804,6 +5811,10 @@
             <a:prstDash val="solid"/>
           </a:ln>
         </p:spPr>
+        <p:txBody>
+          <a:bodyPr/>
+          <a:p/>
+        </p:txBody>
       </p:sp>
       <p:sp>
         <p:nvSpPr>
@@ -6050,55 +6061,7 @@
                   <a:srgbClr val="17202A"/>
                 </a:solidFill>
               </a:rPr>
-              <a:t>• Evita </a:t>
-            </a:r>
-            <a:r>
-              <a:rPr sz="1650" b="0" dirty="0" err="1">
-                <a:solidFill>
-                  <a:srgbClr val="17202A"/>
-                </a:solidFill>
-              </a:rPr>
-              <a:t>sobreajuste</a:t>
-            </a:r>
-            <a:r>
-              <a:rPr sz="1650" b="0" dirty="0">
-                <a:solidFill>
-                  <a:srgbClr val="17202A"/>
-                </a:solidFill>
-              </a:rPr>
-              <a:t> con </a:t>
-            </a:r>
-            <a:r>
-              <a:rPr sz="1650" b="0" dirty="0" err="1">
-                <a:solidFill>
-                  <a:srgbClr val="17202A"/>
-                </a:solidFill>
-              </a:rPr>
-              <a:t>cinco</a:t>
-            </a:r>
-            <a:r>
-              <a:rPr sz="1650" b="0" dirty="0">
-                <a:solidFill>
-                  <a:srgbClr val="17202A"/>
-                </a:solidFill>
-              </a:rPr>
-              <a:t> meses de </a:t>
-            </a:r>
-            <a:r>
-              <a:rPr sz="1650" b="0" dirty="0" err="1">
-                <a:solidFill>
-                  <a:srgbClr val="17202A"/>
-                </a:solidFill>
-              </a:rPr>
-              <a:t>datos</a:t>
-            </a:r>
-            <a:r>
-              <a:rPr sz="1650" b="0" dirty="0">
-                <a:solidFill>
-                  <a:srgbClr val="17202A"/>
-                </a:solidFill>
-              </a:rPr>
-              <a:t>.</a:t>
+              <a:t>• Comparado con una Regresión Lineal (scikit-learn).</a:t>
             </a:r>
           </a:p>
         </p:txBody>
@@ -6137,6 +6100,10 @@
             <a:prstDash val="solid"/>
           </a:ln>
         </p:spPr>
+        <p:txBody>
+          <a:bodyPr/>
+          <a:p/>
+        </p:txBody>
       </p:sp>
       <p:sp>
         <p:nvSpPr>
@@ -6183,7 +6150,7 @@
                   <a:srgbClr val="0F766E"/>
                 </a:solidFill>
               </a:rPr>
-              <a:t>Evaluación</a:t>
+              <a:t>Evaluación · R² 0,53</a:t>
             </a:r>
           </a:p>
         </p:txBody>
@@ -6222,6 +6189,10 @@
             <a:prstDash val="solid"/>
           </a:ln>
         </p:spPr>
+        <p:txBody>
+          <a:bodyPr/>
+          <a:p/>
+        </p:txBody>
       </p:sp>
       <p:sp>
         <p:nvSpPr>
@@ -6357,6 +6328,10 @@
             <a:prstDash val="solid"/>
           </a:ln>
         </p:spPr>
+        <p:txBody>
+          <a:bodyPr/>
+          <a:p/>
+        </p:txBody>
       </p:sp>
       <p:sp>
         <p:nvSpPr>
@@ -6503,111 +6478,7 @@
                   <a:srgbClr val="17202A"/>
                 </a:solidFill>
               </a:rPr>
-              <a:t>Mensaje</a:t>
-            </a:r>
-            <a:r>
-              <a:rPr sz="1800" b="1" dirty="0">
-                <a:solidFill>
-                  <a:srgbClr val="17202A"/>
-                </a:solidFill>
-              </a:rPr>
-              <a:t> de defensa: es un </a:t>
-            </a:r>
-            <a:r>
-              <a:rPr sz="1800" b="1" dirty="0" err="1">
-                <a:solidFill>
-                  <a:srgbClr val="17202A"/>
-                </a:solidFill>
-              </a:rPr>
-              <a:t>modelo</a:t>
-            </a:r>
-            <a:r>
-              <a:rPr sz="1800" b="1" dirty="0">
-                <a:solidFill>
-                  <a:srgbClr val="17202A"/>
-                </a:solidFill>
-              </a:rPr>
-              <a:t> </a:t>
-            </a:r>
-            <a:r>
-              <a:rPr sz="1800" b="1" dirty="0" err="1">
-                <a:solidFill>
-                  <a:srgbClr val="17202A"/>
-                </a:solidFill>
-              </a:rPr>
-              <a:t>exploratorio</a:t>
-            </a:r>
-            <a:r>
-              <a:rPr sz="1800" b="1" dirty="0">
-                <a:solidFill>
-                  <a:srgbClr val="17202A"/>
-                </a:solidFill>
-              </a:rPr>
-              <a:t> para </a:t>
-            </a:r>
-            <a:r>
-              <a:rPr sz="1800" b="1" dirty="0" err="1">
-                <a:solidFill>
-                  <a:srgbClr val="17202A"/>
-                </a:solidFill>
-              </a:rPr>
-              <a:t>priorizar</a:t>
-            </a:r>
-            <a:r>
-              <a:rPr sz="1800" b="1" dirty="0">
-                <a:solidFill>
-                  <a:srgbClr val="17202A"/>
-                </a:solidFill>
-              </a:rPr>
-              <a:t>, no un </a:t>
-            </a:r>
-            <a:r>
-              <a:rPr sz="1800" b="1" dirty="0" err="1">
-                <a:solidFill>
-                  <a:srgbClr val="17202A"/>
-                </a:solidFill>
-              </a:rPr>
-              <a:t>pronóstico</a:t>
-            </a:r>
-            <a:r>
-              <a:rPr sz="1800" b="1" dirty="0">
-                <a:solidFill>
-                  <a:srgbClr val="17202A"/>
-                </a:solidFill>
-              </a:rPr>
-              <a:t> </a:t>
-            </a:r>
-            <a:r>
-              <a:rPr sz="1800" b="1" dirty="0" err="1">
-                <a:solidFill>
-                  <a:srgbClr val="17202A"/>
-                </a:solidFill>
-              </a:rPr>
-              <a:t>operativo</a:t>
-            </a:r>
-            <a:r>
-              <a:rPr sz="1800" b="1" dirty="0">
-                <a:solidFill>
-                  <a:srgbClr val="17202A"/>
-                </a:solidFill>
-              </a:rPr>
-              <a:t> </a:t>
-            </a:r>
-            <a:r>
-              <a:rPr sz="1800" b="1" dirty="0" err="1">
-                <a:solidFill>
-                  <a:srgbClr val="17202A"/>
-                </a:solidFill>
-              </a:rPr>
-              <a:t>definitivo</a:t>
-            </a:r>
-            <a:r>
-              <a:rPr sz="1800" b="1" dirty="0">
-                <a:solidFill>
-                  <a:srgbClr val="17202A"/>
-                </a:solidFill>
-              </a:rPr>
-              <a:t>.</a:t>
+              <a:t>El baseline (R² 0,53) iguala a la Regresión Lineal (R² 0,53): se mantiene por ser más explicable y auditable.</a:t>
             </a:r>
           </a:p>
         </p:txBody>
@@ -7468,7 +7339,7 @@
                   <a:srgbClr val="17202A"/>
                 </a:solidFill>
               </a:rPr>
-              <a:t>• Siguiente mejora: incorporar más meses y comparar contra modelos clásicos.</a:t>
+              <a:t>• Modelo validado contra Regresión Lineal (R² 0,53); mejora futura: más meses y tasas por provincia.</a:t>
             </a:r>
           </a:p>
         </p:txBody>

</xml_diff>

<commit_message>
Eliminar archivos obsoletos y agregar documentación del proyecto y justificación del modelo predictivo
</commit_message>
<xml_diff>
--- a/informe/DEFENSA_SAFEANALYTICS_EC.pptx
+++ b/informe/DEFENSA_SAFEANALYTICS_EC.pptx
@@ -115,6 +115,11 @@
       </a:defRPr>
     </a:lvl9pPr>
   </p:defaultTextStyle>
+  <p:extLst>
+    <p:ext uri="{EFAFB233-063F-42B5-8137-9DF3F51BA10A}">
+      <p15:sldGuideLst xmlns:p15="http://schemas.microsoft.com/office/powerpoint/2012/main"/>
+    </p:ext>
+  </p:extLst>
 </p:presentation>
 </file>
 
@@ -140,7 +145,7 @@
           </c:tx>
           <c:spPr>
             <a:solidFill>
-              <a:schemeClr val="accent1"/>
+              <a:srgbClr val="156082"/>
             </a:solidFill>
           </c:spPr>
           <c:invertIfNegative val="1"/>
@@ -2071,56 +2076,6 @@
       </p:sp>
       <p:sp>
         <p:nvSpPr>
-          <p:cNvPr id="9" name="Rectángulo 8">
-            <a:extLst>
-              <a:ext uri="{FF2B5EF4-FFF2-40B4-BE49-F238E27FC236}">
-                <a16:creationId xmlns:a16="http://schemas.microsoft.com/office/drawing/2014/main" id="{F81F544B-A1B3-472A-A54D-C83DD7C88883}"/>
-              </a:ext>
-            </a:extLst>
-          </p:cNvPr>
-          <p:cNvSpPr>
-            <a:spLocks noGrp="1"/>
-          </p:cNvSpPr>
-          <p:nvPr/>
-        </p:nvSpPr>
-        <p:spPr>
-          <a:xfrm>
-            <a:off x="685800" y="6381750"/>
-            <a:ext cx="9906000" cy="228600"/>
-          </a:xfrm>
-          <a:prstGeom prst="rect">
-            <a:avLst/>
-          </a:prstGeom>
-          <a:noFill/>
-          <a:ln w="0">
-            <a:noFill/>
-            <a:prstDash val="solid"/>
-          </a:ln>
-        </p:spPr>
-        <p:txBody>
-          <a:bodyPr/>
-          <a:lstStyle/>
-          <a:p>
-            <a:pPr>
-              <a:defRPr sz="975">
-                <a:solidFill>
-                  <a:srgbClr val="617080"/>
-                </a:solidFill>
-              </a:defRPr>
-            </a:pPr>
-            <a:r>
-              <a:rPr sz="975">
-                <a:solidFill>
-                  <a:srgbClr val="617080"/>
-                </a:solidFill>
-              </a:rPr>
-              <a:t>SafeAnalytics EC | Proyecto Integrador 7A</a:t>
-            </a:r>
-          </a:p>
-        </p:txBody>
-      </p:sp>
-      <p:sp>
-        <p:nvSpPr>
           <p:cNvPr id="10" name="Rectángulo 9">
             <a:extLst>
               <a:ext uri="{FF2B5EF4-FFF2-40B4-BE49-F238E27FC236}">
@@ -2544,56 +2499,6 @@
       </p:sp>
       <p:sp>
         <p:nvSpPr>
-          <p:cNvPr id="8" name="Rectángulo 7">
-            <a:extLst>
-              <a:ext uri="{FF2B5EF4-FFF2-40B4-BE49-F238E27FC236}">
-                <a16:creationId xmlns:a16="http://schemas.microsoft.com/office/drawing/2014/main" id="{1BDF7404-3185-43BC-91FF-DBD66AC083AB}"/>
-              </a:ext>
-            </a:extLst>
-          </p:cNvPr>
-          <p:cNvSpPr>
-            <a:spLocks noGrp="1"/>
-          </p:cNvSpPr>
-          <p:nvPr/>
-        </p:nvSpPr>
-        <p:spPr>
-          <a:xfrm>
-            <a:off x="685800" y="6381750"/>
-            <a:ext cx="9906000" cy="228600"/>
-          </a:xfrm>
-          <a:prstGeom prst="rect">
-            <a:avLst/>
-          </a:prstGeom>
-          <a:noFill/>
-          <a:ln w="0">
-            <a:noFill/>
-            <a:prstDash val="solid"/>
-          </a:ln>
-        </p:spPr>
-        <p:txBody>
-          <a:bodyPr/>
-          <a:lstStyle/>
-          <a:p>
-            <a:pPr>
-              <a:defRPr sz="975">
-                <a:solidFill>
-                  <a:srgbClr val="617080"/>
-                </a:solidFill>
-              </a:defRPr>
-            </a:pPr>
-            <a:r>
-              <a:rPr sz="975">
-                <a:solidFill>
-                  <a:srgbClr val="617080"/>
-                </a:solidFill>
-              </a:rPr>
-              <a:t>SafeAnalytics EC | Proyecto Integrador 7A</a:t>
-            </a:r>
-          </a:p>
-        </p:txBody>
-      </p:sp>
-      <p:sp>
-        <p:nvSpPr>
           <p:cNvPr id="9" name="Rectángulo 8">
             <a:extLst>
               <a:ext uri="{FF2B5EF4-FFF2-40B4-BE49-F238E27FC236}">
@@ -2766,7 +2671,10 @@
         </p:spPr>
         <p:txBody>
           <a:bodyPr/>
-          <a:p/>
+          <a:lstStyle/>
+          <a:p>
+            <a:endParaRPr/>
+          </a:p>
         </p:txBody>
       </p:sp>
       <p:sp>
@@ -2905,7 +2813,10 @@
         </p:spPr>
         <p:txBody>
           <a:bodyPr/>
-          <a:p/>
+          <a:lstStyle/>
+          <a:p>
+            <a:endParaRPr/>
+          </a:p>
         </p:txBody>
       </p:sp>
       <p:sp>
@@ -3044,7 +2955,10 @@
         </p:spPr>
         <p:txBody>
           <a:bodyPr/>
-          <a:p/>
+          <a:lstStyle/>
+          <a:p>
+            <a:endParaRPr/>
+          </a:p>
         </p:txBody>
       </p:sp>
       <p:sp>
@@ -3183,7 +3097,10 @@
         </p:spPr>
         <p:txBody>
           <a:bodyPr/>
-          <a:p/>
+          <a:lstStyle/>
+          <a:p>
+            <a:endParaRPr/>
+          </a:p>
         </p:txBody>
       </p:sp>
       <p:sp>
@@ -3432,56 +3349,6 @@
                 </a:solidFill>
               </a:rPr>
               <a:t>• Índice de riesgo y simulador para pasar del dato a la acción.</a:t>
-            </a:r>
-          </a:p>
-        </p:txBody>
-      </p:sp>
-      <p:sp>
-        <p:nvSpPr>
-          <p:cNvPr id="17" name="Rectángulo 16">
-            <a:extLst>
-              <a:ext uri="{FF2B5EF4-FFF2-40B4-BE49-F238E27FC236}">
-                <a16:creationId xmlns:a16="http://schemas.microsoft.com/office/drawing/2014/main" id="{E0C8151A-5374-4D45-A67B-93F425031591}"/>
-              </a:ext>
-            </a:extLst>
-          </p:cNvPr>
-          <p:cNvSpPr>
-            <a:spLocks noGrp="1"/>
-          </p:cNvSpPr>
-          <p:nvPr/>
-        </p:nvSpPr>
-        <p:spPr>
-          <a:xfrm>
-            <a:off x="685800" y="6381750"/>
-            <a:ext cx="9906000" cy="228600"/>
-          </a:xfrm>
-          <a:prstGeom prst="rect">
-            <a:avLst/>
-          </a:prstGeom>
-          <a:noFill/>
-          <a:ln w="0">
-            <a:noFill/>
-            <a:prstDash val="solid"/>
-          </a:ln>
-        </p:spPr>
-        <p:txBody>
-          <a:bodyPr/>
-          <a:lstStyle/>
-          <a:p>
-            <a:pPr>
-              <a:defRPr sz="975">
-                <a:solidFill>
-                  <a:srgbClr val="617080"/>
-                </a:solidFill>
-              </a:defRPr>
-            </a:pPr>
-            <a:r>
-              <a:rPr sz="975">
-                <a:solidFill>
-                  <a:srgbClr val="617080"/>
-                </a:solidFill>
-              </a:rPr>
-              <a:t>SafeAnalytics EC | Proyecto Integrador 7A</a:t>
             </a:r>
           </a:p>
         </p:txBody>
@@ -3660,7 +3527,10 @@
         </p:spPr>
         <p:txBody>
           <a:bodyPr/>
-          <a:p/>
+          <a:lstStyle/>
+          <a:p>
+            <a:endParaRPr/>
+          </a:p>
         </p:txBody>
       </p:sp>
       <p:sp>
@@ -4398,56 +4268,6 @@
                 </a:solidFill>
               </a:rPr>
               <a:t>Resultado: datos reproducibles, auditables y listos para análisis multidimensional.</a:t>
-            </a:r>
-          </a:p>
-        </p:txBody>
-      </p:sp>
-      <p:sp>
-        <p:nvSpPr>
-          <p:cNvPr id="18" name="Rectángulo 17">
-            <a:extLst>
-              <a:ext uri="{FF2B5EF4-FFF2-40B4-BE49-F238E27FC236}">
-                <a16:creationId xmlns:a16="http://schemas.microsoft.com/office/drawing/2014/main" id="{79B85241-C0AC-4134-8ABD-B95B3F2F0538}"/>
-              </a:ext>
-            </a:extLst>
-          </p:cNvPr>
-          <p:cNvSpPr>
-            <a:spLocks noGrp="1"/>
-          </p:cNvSpPr>
-          <p:nvPr/>
-        </p:nvSpPr>
-        <p:spPr>
-          <a:xfrm>
-            <a:off x="685800" y="6381750"/>
-            <a:ext cx="9906000" cy="228600"/>
-          </a:xfrm>
-          <a:prstGeom prst="rect">
-            <a:avLst/>
-          </a:prstGeom>
-          <a:noFill/>
-          <a:ln w="0">
-            <a:noFill/>
-            <a:prstDash val="solid"/>
-          </a:ln>
-        </p:spPr>
-        <p:txBody>
-          <a:bodyPr/>
-          <a:lstStyle/>
-          <a:p>
-            <a:pPr>
-              <a:defRPr sz="975">
-                <a:solidFill>
-                  <a:srgbClr val="617080"/>
-                </a:solidFill>
-              </a:defRPr>
-            </a:pPr>
-            <a:r>
-              <a:rPr sz="975">
-                <a:solidFill>
-                  <a:srgbClr val="617080"/>
-                </a:solidFill>
-              </a:rPr>
-              <a:t>SafeAnalytics EC | Proyecto Integrador 7A</a:t>
             </a:r>
           </a:p>
         </p:txBody>
@@ -4642,7 +4462,10 @@
         </p:spPr>
         <p:txBody>
           <a:bodyPr/>
-          <a:p/>
+          <a:lstStyle/>
+          <a:p>
+            <a:endParaRPr/>
+          </a:p>
         </p:txBody>
       </p:sp>
       <p:sp>
@@ -4841,56 +4664,6 @@
                 </a:solidFill>
               </a:rPr>
               <a:t>• Volumen y cantones correlacionan r=0,91; no es causalidad.</a:t>
-            </a:r>
-          </a:p>
-        </p:txBody>
-      </p:sp>
-      <p:sp>
-        <p:nvSpPr>
-          <p:cNvPr id="8" name="Rectángulo 7">
-            <a:extLst>
-              <a:ext uri="{FF2B5EF4-FFF2-40B4-BE49-F238E27FC236}">
-                <a16:creationId xmlns:a16="http://schemas.microsoft.com/office/drawing/2014/main" id="{BDD97A4A-67AB-4917-A0BF-27D5F097692F}"/>
-              </a:ext>
-            </a:extLst>
-          </p:cNvPr>
-          <p:cNvSpPr>
-            <a:spLocks noGrp="1"/>
-          </p:cNvSpPr>
-          <p:nvPr/>
-        </p:nvSpPr>
-        <p:spPr>
-          <a:xfrm>
-            <a:off x="685800" y="6381750"/>
-            <a:ext cx="9906000" cy="228600"/>
-          </a:xfrm>
-          <a:prstGeom prst="rect">
-            <a:avLst/>
-          </a:prstGeom>
-          <a:noFill/>
-          <a:ln w="0">
-            <a:noFill/>
-            <a:prstDash val="solid"/>
-          </a:ln>
-        </p:spPr>
-        <p:txBody>
-          <a:bodyPr/>
-          <a:lstStyle/>
-          <a:p>
-            <a:pPr>
-              <a:defRPr sz="975">
-                <a:solidFill>
-                  <a:srgbClr val="617080"/>
-                </a:solidFill>
-              </a:defRPr>
-            </a:pPr>
-            <a:r>
-              <a:rPr sz="975">
-                <a:solidFill>
-                  <a:srgbClr val="617080"/>
-                </a:solidFill>
-              </a:rPr>
-              <a:t>SafeAnalytics EC | Proyecto Integrador 7A</a:t>
             </a:r>
           </a:p>
         </p:txBody>
@@ -5591,56 +5364,6 @@
       </p:sp>
       <p:sp>
         <p:nvSpPr>
-          <p:cNvPr id="15" name="Rectángulo 14">
-            <a:extLst>
-              <a:ext uri="{FF2B5EF4-FFF2-40B4-BE49-F238E27FC236}">
-                <a16:creationId xmlns:a16="http://schemas.microsoft.com/office/drawing/2014/main" id="{076CD08B-FC76-4E9A-9B45-34BD7ECC1EDF}"/>
-              </a:ext>
-            </a:extLst>
-          </p:cNvPr>
-          <p:cNvSpPr>
-            <a:spLocks noGrp="1"/>
-          </p:cNvSpPr>
-          <p:nvPr/>
-        </p:nvSpPr>
-        <p:spPr>
-          <a:xfrm>
-            <a:off x="685800" y="6381750"/>
-            <a:ext cx="9906000" cy="228600"/>
-          </a:xfrm>
-          <a:prstGeom prst="rect">
-            <a:avLst/>
-          </a:prstGeom>
-          <a:noFill/>
-          <a:ln w="0">
-            <a:noFill/>
-            <a:prstDash val="solid"/>
-          </a:ln>
-        </p:spPr>
-        <p:txBody>
-          <a:bodyPr/>
-          <a:lstStyle/>
-          <a:p>
-            <a:pPr>
-              <a:defRPr sz="975">
-                <a:solidFill>
-                  <a:srgbClr val="617080"/>
-                </a:solidFill>
-              </a:defRPr>
-            </a:pPr>
-            <a:r>
-              <a:rPr sz="975">
-                <a:solidFill>
-                  <a:srgbClr val="617080"/>
-                </a:solidFill>
-              </a:rPr>
-              <a:t>SafeAnalytics EC | Proyecto Integrador 7A</a:t>
-            </a:r>
-          </a:p>
-        </p:txBody>
-      </p:sp>
-      <p:sp>
-        <p:nvSpPr>
           <p:cNvPr id="16" name="Rectángulo 15">
             <a:extLst>
               <a:ext uri="{FF2B5EF4-FFF2-40B4-BE49-F238E27FC236}">
@@ -5813,7 +5536,10 @@
         </p:spPr>
         <p:txBody>
           <a:bodyPr/>
-          <a:p/>
+          <a:lstStyle/>
+          <a:p>
+            <a:endParaRPr/>
+          </a:p>
         </p:txBody>
       </p:sp>
       <p:sp>
@@ -6102,7 +5828,10 @@
         </p:spPr>
         <p:txBody>
           <a:bodyPr/>
-          <a:p/>
+          <a:lstStyle/>
+          <a:p>
+            <a:endParaRPr/>
+          </a:p>
         </p:txBody>
       </p:sp>
       <p:sp>
@@ -6191,7 +5920,10 @@
         </p:spPr>
         <p:txBody>
           <a:bodyPr/>
-          <a:p/>
+          <a:lstStyle/>
+          <a:p>
+            <a:endParaRPr/>
+          </a:p>
         </p:txBody>
       </p:sp>
       <p:sp>
@@ -6330,7 +6062,10 @@
         </p:spPr>
         <p:txBody>
           <a:bodyPr/>
-          <a:p/>
+          <a:lstStyle/>
+          <a:p>
+            <a:endParaRPr/>
+          </a:p>
         </p:txBody>
       </p:sp>
       <p:sp>
@@ -6479,56 +6214,6 @@
                 </a:solidFill>
               </a:rPr>
               <a:t>El baseline (R² 0,53) iguala a la Regresión Lineal (R² 0,53): se mantiene por ser más explicable y auditable.</a:t>
-            </a:r>
-          </a:p>
-        </p:txBody>
-      </p:sp>
-      <p:sp>
-        <p:nvSpPr>
-          <p:cNvPr id="17" name="Rectángulo 16">
-            <a:extLst>
-              <a:ext uri="{FF2B5EF4-FFF2-40B4-BE49-F238E27FC236}">
-                <a16:creationId xmlns:a16="http://schemas.microsoft.com/office/drawing/2014/main" id="{EA5C14BE-DF66-4C35-BF92-D79FA9F9C170}"/>
-              </a:ext>
-            </a:extLst>
-          </p:cNvPr>
-          <p:cNvSpPr>
-            <a:spLocks noGrp="1"/>
-          </p:cNvSpPr>
-          <p:nvPr/>
-        </p:nvSpPr>
-        <p:spPr>
-          <a:xfrm>
-            <a:off x="685800" y="6381750"/>
-            <a:ext cx="9906000" cy="228600"/>
-          </a:xfrm>
-          <a:prstGeom prst="rect">
-            <a:avLst/>
-          </a:prstGeom>
-          <a:noFill/>
-          <a:ln w="0">
-            <a:noFill/>
-            <a:prstDash val="solid"/>
-          </a:ln>
-        </p:spPr>
-        <p:txBody>
-          <a:bodyPr/>
-          <a:lstStyle/>
-          <a:p>
-            <a:pPr>
-              <a:defRPr sz="975">
-                <a:solidFill>
-                  <a:srgbClr val="617080"/>
-                </a:solidFill>
-              </a:defRPr>
-            </a:pPr>
-            <a:r>
-              <a:rPr sz="975">
-                <a:solidFill>
-                  <a:srgbClr val="617080"/>
-                </a:solidFill>
-              </a:rPr>
-              <a:t>SafeAnalytics EC | Proyecto Integrador 7A</a:t>
             </a:r>
           </a:p>
         </p:txBody>
@@ -6958,56 +6643,6 @@
       </p:sp>
       <p:sp>
         <p:nvSpPr>
-          <p:cNvPr id="8" name="Rectángulo 7">
-            <a:extLst>
-              <a:ext uri="{FF2B5EF4-FFF2-40B4-BE49-F238E27FC236}">
-                <a16:creationId xmlns:a16="http://schemas.microsoft.com/office/drawing/2014/main" id="{71F0CC5B-88D2-4DA4-BDF4-B2794853CD0D}"/>
-              </a:ext>
-            </a:extLst>
-          </p:cNvPr>
-          <p:cNvSpPr>
-            <a:spLocks noGrp="1"/>
-          </p:cNvSpPr>
-          <p:nvPr/>
-        </p:nvSpPr>
-        <p:spPr>
-          <a:xfrm>
-            <a:off x="685800" y="6381750"/>
-            <a:ext cx="9906000" cy="228600"/>
-          </a:xfrm>
-          <a:prstGeom prst="rect">
-            <a:avLst/>
-          </a:prstGeom>
-          <a:noFill/>
-          <a:ln w="0">
-            <a:noFill/>
-            <a:prstDash val="solid"/>
-          </a:ln>
-        </p:spPr>
-        <p:txBody>
-          <a:bodyPr/>
-          <a:lstStyle/>
-          <a:p>
-            <a:pPr>
-              <a:defRPr sz="975">
-                <a:solidFill>
-                  <a:srgbClr val="617080"/>
-                </a:solidFill>
-              </a:defRPr>
-            </a:pPr>
-            <a:r>
-              <a:rPr sz="975">
-                <a:solidFill>
-                  <a:srgbClr val="617080"/>
-                </a:solidFill>
-              </a:rPr>
-              <a:t>SafeAnalytics EC | Proyecto Integrador 7A</a:t>
-            </a:r>
-          </a:p>
-        </p:txBody>
-      </p:sp>
-      <p:sp>
-        <p:nvSpPr>
           <p:cNvPr id="9" name="Rectángulo 8">
             <a:extLst>
               <a:ext uri="{FF2B5EF4-FFF2-40B4-BE49-F238E27FC236}">
@@ -7425,56 +7060,6 @@
                 </a:solidFill>
               </a:rPr>
               <a:t>Cierre: los datos dejan de ser reportes aislados y se convierten en inteligencia accionable.</a:t>
-            </a:r>
-          </a:p>
-        </p:txBody>
-      </p:sp>
-      <p:sp>
-        <p:nvSpPr>
-          <p:cNvPr id="8" name="Rectángulo 7">
-            <a:extLst>
-              <a:ext uri="{FF2B5EF4-FFF2-40B4-BE49-F238E27FC236}">
-                <a16:creationId xmlns:a16="http://schemas.microsoft.com/office/drawing/2014/main" id="{2FD4474D-231A-45D9-A185-74C2785869F1}"/>
-              </a:ext>
-            </a:extLst>
-          </p:cNvPr>
-          <p:cNvSpPr>
-            <a:spLocks noGrp="1"/>
-          </p:cNvSpPr>
-          <p:nvPr/>
-        </p:nvSpPr>
-        <p:spPr>
-          <a:xfrm>
-            <a:off x="685800" y="6381750"/>
-            <a:ext cx="9906000" cy="228600"/>
-          </a:xfrm>
-          <a:prstGeom prst="rect">
-            <a:avLst/>
-          </a:prstGeom>
-          <a:noFill/>
-          <a:ln w="0">
-            <a:noFill/>
-            <a:prstDash val="solid"/>
-          </a:ln>
-        </p:spPr>
-        <p:txBody>
-          <a:bodyPr/>
-          <a:lstStyle/>
-          <a:p>
-            <a:pPr>
-              <a:defRPr sz="975">
-                <a:solidFill>
-                  <a:srgbClr val="617080"/>
-                </a:solidFill>
-              </a:defRPr>
-            </a:pPr>
-            <a:r>
-              <a:rPr sz="975">
-                <a:solidFill>
-                  <a:srgbClr val="617080"/>
-                </a:solidFill>
-              </a:rPr>
-              <a:t>SafeAnalytics EC | Proyecto Integrador 7A</a:t>
             </a:r>
           </a:p>
         </p:txBody>

</xml_diff>